<commit_message>
Use the cleaner status screenshot in the deck and report
The earlier capture included a failed icacls command and two rejected ssh
attempts before the successful one, which reads as a troubleshooting log
rather than evidence. Replaced with a clean capture showing the ssh config
shortcut connecting and both containers healthy, with the api publishing
8000/tcp internally and nginx publishing 0.0.0.0:80->80/tcp.

Co-Authored-By: Claude Opus 5 <noreply@anthropic.com>
</commit_message>
<xml_diff>
--- a/docs/DA510_Assignment2_Demo.pptx
+++ b/docs/DA510_Assignment2_Demo.pptx
@@ -950,7 +950,7 @@
           <a:p>
             <a:r>
               <a:rPr lang="en-US" dirty="0"/>
-              <a:t>Backup in case the live demo fails. api shows 8000/tcp with no host binding; nginx shows 0.0.0.0:80-&gt;80/tcp.</a:t>
+              <a:t>Backup in case the live demo fails. ssh da510 connects, api shows 8000/tcp with no host binding, nginx shows 0.0.0.0:80-&gt;80/tcp.</a:t>
             </a:r>
             <a:endParaRPr lang="en-US" dirty="0"/>
           </a:p>
@@ -3767,8 +3767,8 @@
         </p:blipFill>
         <p:spPr>
           <a:xfrm>
-            <a:off x="731520" y="1005840"/>
-            <a:ext cx="7680960" cy="3768471"/>
+            <a:off x="457200" y="1234440"/>
+            <a:ext cx="8229600" cy="2628329"/>
           </a:xfrm>
           <a:prstGeom prst="rect">
             <a:avLst/>

</xml_diff>